<commit_message>
Fix: previous rename commit missed the content edits
The prior commit renamed the folder but a failed `git add` (invalid
pathspec for the already-moved old directory) meant it silently kept
the old name inside SKILL.md's frontmatter and the old registration
paths in GUIDE.md/GETTING-STARTED.md. This actually applies those edits.
Also picks up the rebuilt reference-deck.pptx from re-running the build
after the rename (paths resolve via __dirname so content is unchanged,
just re-saved).

Co-Authored-By: Claude Sonnet 5 <noreply@anthropic.com>
Claude-Session: https://claude.ai/code/session_01Kj5xV5Exwur6E1UfGWAcca
</commit_message>
<xml_diff>
--- a/libeo-client-slides/reference-deck.pptx
+++ b/libeo-client-slides/reference-deck.pptx
@@ -3651,7 +3651,7 @@
       </p:grpSpPr>
       <p:pic>
         <p:nvPicPr>
-          <p:cNvPr id="2" name="Image 0" descr="/home/user/skill1/ouchi-no-mikata-slides/assets/dot-texture-blue.png">    </p:cNvPr>
+          <p:cNvPr id="2" name="Image 0" descr="/home/user/skill1/libeo-client-slides/assets/dot-texture-blue.png">    </p:cNvPr>
           <p:cNvPicPr>
             <a:picLocks noChangeAspect="1"/>
           </p:cNvPicPr>
@@ -4790,7 +4790,7 @@
       </p:sp>
       <p:pic>
         <p:nvPicPr>
-          <p:cNvPr id="11" name="Image 0" descr="/home/user/skill1/ouchi-no-mikata-slides/assets/icons/document.png">    </p:cNvPr>
+          <p:cNvPr id="11" name="Image 0" descr="/home/user/skill1/libeo-client-slides/assets/icons/document.png">    </p:cNvPr>
           <p:cNvPicPr>
             <a:picLocks noChangeAspect="1"/>
           </p:cNvPicPr>
@@ -4946,7 +4946,7 @@
       </p:sp>
       <p:pic>
         <p:nvPicPr>
-          <p:cNvPr id="16" name="Image 1" descr="/home/user/skill1/ouchi-no-mikata-slides/assets/icons/funnel.png">    </p:cNvPr>
+          <p:cNvPr id="16" name="Image 1" descr="/home/user/skill1/libeo-client-slides/assets/icons/funnel.png">    </p:cNvPr>
           <p:cNvPicPr>
             <a:picLocks noChangeAspect="1"/>
           </p:cNvPicPr>
@@ -5102,7 +5102,7 @@
       </p:sp>
       <p:pic>
         <p:nvPicPr>
-          <p:cNvPr id="21" name="Image 2" descr="/home/user/skill1/ouchi-no-mikata-slides/assets/icons/megaphone.png">    </p:cNvPr>
+          <p:cNvPr id="21" name="Image 2" descr="/home/user/skill1/libeo-client-slides/assets/icons/megaphone.png">    </p:cNvPr>
           <p:cNvPicPr>
             <a:picLocks noChangeAspect="1"/>
           </p:cNvPicPr>
@@ -17984,7 +17984,7 @@
       </p:sp>
       <p:pic>
         <p:nvPicPr>
-          <p:cNvPr id="13" name="Image 0" descr="/home/user/skill1/ouchi-no-mikata-slides/assets/icons/search.png">    </p:cNvPr>
+          <p:cNvPr id="13" name="Image 0" descr="/home/user/skill1/libeo-client-slides/assets/icons/search.png">    </p:cNvPr>
           <p:cNvPicPr>
             <a:picLocks noChangeAspect="1"/>
           </p:cNvPicPr>
@@ -18074,7 +18074,7 @@
       </p:sp>
       <p:pic>
         <p:nvPicPr>
-          <p:cNvPr id="16" name="Image 1" descr="/home/user/skill1/ouchi-no-mikata-slides/assets/icons/funnel.png">    </p:cNvPr>
+          <p:cNvPr id="16" name="Image 1" descr="/home/user/skill1/libeo-client-slides/assets/icons/funnel.png">    </p:cNvPr>
           <p:cNvPicPr>
             <a:picLocks noChangeAspect="1"/>
           </p:cNvPicPr>
@@ -18164,7 +18164,7 @@
       </p:sp>
       <p:pic>
         <p:nvPicPr>
-          <p:cNvPr id="19" name="Image 2" descr="/home/user/skill1/ouchi-no-mikata-slides/assets/icons/document.png">    </p:cNvPr>
+          <p:cNvPr id="19" name="Image 2" descr="/home/user/skill1/libeo-client-slides/assets/icons/document.png">    </p:cNvPr>
           <p:cNvPicPr>
             <a:picLocks noChangeAspect="1"/>
           </p:cNvPicPr>
@@ -18254,7 +18254,7 @@
       </p:sp>
       <p:pic>
         <p:nvPicPr>
-          <p:cNvPr id="22" name="Image 3" descr="/home/user/skill1/ouchi-no-mikata-slides/assets/icons/refresh.png">    </p:cNvPr>
+          <p:cNvPr id="22" name="Image 3" descr="/home/user/skill1/libeo-client-slides/assets/icons/refresh.png">    </p:cNvPr>
           <p:cNvPicPr>
             <a:picLocks noChangeAspect="1"/>
           </p:cNvPicPr>
@@ -18613,7 +18613,7 @@
       </p:sp>
       <p:pic>
         <p:nvPicPr>
-          <p:cNvPr id="11" name="Image 0" descr="/home/user/skill1/ouchi-no-mikata-slides/assets/icons/check.png">    </p:cNvPr>
+          <p:cNvPr id="11" name="Image 0" descr="/home/user/skill1/libeo-client-slides/assets/icons/check.png">    </p:cNvPr>
           <p:cNvPicPr>
             <a:picLocks noChangeAspect="1"/>
           </p:cNvPicPr>
@@ -18718,7 +18718,7 @@
       </p:sp>
       <p:pic>
         <p:nvPicPr>
-          <p:cNvPr id="15" name="Image 1" descr="/home/user/skill1/ouchi-no-mikata-slides/assets/icons/check.png">    </p:cNvPr>
+          <p:cNvPr id="15" name="Image 1" descr="/home/user/skill1/libeo-client-slides/assets/icons/check.png">    </p:cNvPr>
           <p:cNvPicPr>
             <a:picLocks noChangeAspect="1"/>
           </p:cNvPicPr>
@@ -18823,7 +18823,7 @@
       </p:sp>
       <p:pic>
         <p:nvPicPr>
-          <p:cNvPr id="19" name="Image 2" descr="/home/user/skill1/ouchi-no-mikata-slides/assets/icons/check.png">    </p:cNvPr>
+          <p:cNvPr id="19" name="Image 2" descr="/home/user/skill1/libeo-client-slides/assets/icons/check.png">    </p:cNvPr>
           <p:cNvPicPr>
             <a:picLocks noChangeAspect="1"/>
           </p:cNvPicPr>
@@ -18977,7 +18977,7 @@
       </p:grpSpPr>
       <p:pic>
         <p:nvPicPr>
-          <p:cNvPr id="2" name="Image 0" descr="/home/user/skill1/ouchi-no-mikata-slides/assets/dot-texture-navy.png">    </p:cNvPr>
+          <p:cNvPr id="2" name="Image 0" descr="/home/user/skill1/libeo-client-slides/assets/dot-texture-navy.png">    </p:cNvPr>
           <p:cNvPicPr>
             <a:picLocks noChangeAspect="1"/>
           </p:cNvPicPr>
@@ -22097,7 +22097,7 @@
       </p:grpSpPr>
       <p:pic>
         <p:nvPicPr>
-          <p:cNvPr id="2" name="Image 0" descr="/home/user/skill1/ouchi-no-mikata-slides/assets/dot-texture-blue.png">    </p:cNvPr>
+          <p:cNvPr id="2" name="Image 0" descr="/home/user/skill1/libeo-client-slides/assets/dot-texture-blue.png">    </p:cNvPr>
           <p:cNvPicPr>
             <a:picLocks noChangeAspect="1"/>
           </p:cNvPicPr>
@@ -23011,7 +23011,7 @@
       </p:grpSpPr>
       <p:pic>
         <p:nvPicPr>
-          <p:cNvPr id="2" name="Image 0" descr="/home/user/skill1/ouchi-no-mikata-slides/assets/dot-texture-navy.png">    </p:cNvPr>
+          <p:cNvPr id="2" name="Image 0" descr="/home/user/skill1/libeo-client-slides/assets/dot-texture-navy.png">    </p:cNvPr>
           <p:cNvPicPr>
             <a:picLocks noChangeAspect="1"/>
           </p:cNvPicPr>
@@ -27394,7 +27394,7 @@
       </p:sp>
       <p:pic>
         <p:nvPicPr>
-          <p:cNvPr id="10" name="Image 0" descr="/home/user/skill1/ouchi-no-mikata-slides/assets/icons/user.png">    </p:cNvPr>
+          <p:cNvPr id="10" name="Image 0" descr="/home/user/skill1/libeo-client-slides/assets/icons/user.png">    </p:cNvPr>
           <p:cNvPicPr>
             <a:picLocks noChangeAspect="1"/>
           </p:cNvPicPr>
@@ -27572,7 +27572,7 @@
       </p:sp>
       <p:pic>
         <p:nvPicPr>
-          <p:cNvPr id="16" name="Image 1" descr="/home/user/skill1/ouchi-no-mikata-slides/assets/icons/search.png">    </p:cNvPr>
+          <p:cNvPr id="16" name="Image 1" descr="/home/user/skill1/libeo-client-slides/assets/icons/search.png">    </p:cNvPr>
           <p:cNvPicPr>
             <a:picLocks noChangeAspect="1"/>
           </p:cNvPicPr>
@@ -27774,7 +27774,7 @@
       </p:sp>
       <p:pic>
         <p:nvPicPr>
-          <p:cNvPr id="21" name="Image 2" descr="/home/user/skill1/ouchi-no-mikata-slides/assets/icons/warning.png">    </p:cNvPr>
+          <p:cNvPr id="21" name="Image 2" descr="/home/user/skill1/libeo-client-slides/assets/icons/warning.png">    </p:cNvPr>
           <p:cNvPicPr>
             <a:picLocks noChangeAspect="1"/>
           </p:cNvPicPr>
@@ -28350,7 +28350,7 @@
       </p:sp>
       <p:pic>
         <p:nvPicPr>
-          <p:cNvPr id="12" name="Image 0" descr="/home/user/skill1/ouchi-no-mikata-slides/assets/icons/warning.png">    </p:cNvPr>
+          <p:cNvPr id="12" name="Image 0" descr="/home/user/skill1/libeo-client-slides/assets/icons/warning.png">    </p:cNvPr>
           <p:cNvPicPr>
             <a:picLocks noChangeAspect="1"/>
           </p:cNvPicPr>
@@ -28595,7 +28595,7 @@
       </p:sp>
       <p:pic>
         <p:nvPicPr>
-          <p:cNvPr id="18" name="Image 1" descr="/home/user/skill1/ouchi-no-mikata-slides/assets/icons/check.png">    </p:cNvPr>
+          <p:cNvPr id="18" name="Image 1" descr="/home/user/skill1/libeo-client-slides/assets/icons/check.png">    </p:cNvPr>
           <p:cNvPicPr>
             <a:picLocks noChangeAspect="1"/>
           </p:cNvPicPr>

</xml_diff>